<commit_message>
Définitions uniques (90 recensées / 88 actives, 35 contrôles) et pages allégées
Données et définitions
- 2 agences Togocom déclarées fermées dans la source (Tabligbo, Awassi
  Onorio) : recensées (90) mais exclues des calculs d'accès (88 actives)
- data.agences_reperes / nombre_controles : source unique des comptes
- Carte des infrastructures : agences actives, couche « fermée » à part
- Libellés « agence active » partout (KPI, tableaux, exports CSV)
- Pied de page et Méthode : 35 contrôles, calculés et non saisis

Ergonomie (C1)
- Bloc « À retenir » en tête de Priorités, Desserte, Plan d'action,
  Méthode et Couverture ; conclusion sous chaque graphique
- Tableaux et détails secondaires repliés après les graphiques

Support
- Mêmes chiffres et libellés sur les diapositives 1, 3, 4, 5, 7, 8, 9, 10
- Pagination alignée sur la position dans le fichier (NN / 10)
- Livrable : contrôle support = tableau de bord (agences, contrôles)
</commit_message>
<xml_diff>
--- a/reports/Defi1_Togo_Connectivite_numerique.pptx
+++ b/reports/Defi1_Togo_Connectivite_numerique.pptx
@@ -3778,7 +3778,7 @@
                 </a:solidFill>
                 <a:latin typeface="Segoe UI"/>
               </a:rPr>
-              <a:t>PRÉFECTURES SANS AUCUNE AGENCE</a:t>
+              <a:t>PRÉFECTURES SANS AGENCE ACTIVE</a:t>
             </a:r>
           </a:p>
         </p:txBody>
@@ -4017,7 +4017,7 @@
                 </a:solidFill>
                 <a:latin typeface="Segoe UI"/>
               </a:rPr>
-              <a:t>Géoportail national (PRISE 2021-2022) · RGPH-5, INSEED (novembre 2022) · limites COD-AB v02, OCHA (2021) — 25 contrôles arithmétiques publiés</a:t>
+              <a:t>Géoportail national (PRISE 2021-2022) · RGPH-5, INSEED (novembre 2022) · limites COD-AB v02, OCHA (2021) — 35 contrôles arithmétiques publiés</a:t>
             </a:r>
           </a:p>
         </p:txBody>
@@ -4562,7 +4562,7 @@
                 </a:solidFill>
                 <a:latin typeface="Consolas"/>
               </a:rPr>
-              <a:t>09 / 9</a:t>
+              <a:t>10 / 10</a:t>
             </a:r>
           </a:p>
         </p:txBody>
@@ -4769,7 +4769,7 @@
                 </a:solidFill>
                 <a:latin typeface="Segoe UI"/>
               </a:rPr>
-              <a:t>90 agences d'opérateur (28 Moov, 62 Togocom) et 3 centres de données, tous à Lomé. « Télécom » est un doublon intégral ; CANAL+ est vide à la source.</a:t>
+              <a:t>90 agences recensées après dédoublonnage (28 Moov, 62 Togocom), dont 88 actives, et 3 centres de données, tous à Lomé. « Télécom » est un doublon ; CANAL+ est vide à la source.</a:t>
             </a:r>
           </a:p>
         </p:txBody>
@@ -6572,7 +6572,7 @@
                 </a:solidFill>
                 <a:latin typeface="Consolas"/>
               </a:rPr>
-              <a:t>01 / 9</a:t>
+              <a:t>02 / 10</a:t>
             </a:r>
           </a:p>
         </p:txBody>
@@ -7520,7 +7520,7 @@
                 </a:solidFill>
                 <a:latin typeface="Consolas"/>
               </a:rPr>
-              <a:t>PRÉFECTURES SANS AUCUNE AGENCE</a:t>
+              <a:t>PRÉFECTURES SANS AGENCE ACTIVE</a:t>
             </a:r>
           </a:p>
         </p:txBody>
@@ -8204,7 +8204,7 @@
                 </a:solidFill>
                 <a:latin typeface="Segoe UI"/>
               </a:rPr>
-              <a:t>Trois sources publiques, trois producteurs — et deux constats qui corrigent l'énoncé du défi : 2 opérateurs et non 4, 90 agences et non 141.</a:t>
+              <a:t>Trois sources publiques, deux corrections de l'énoncé : 2 opérateurs et non 4, 90 agences recensées et non 141.</a:t>
             </a:r>
           </a:p>
         </p:txBody>
@@ -8326,7 +8326,7 @@
                 </a:solidFill>
                 <a:latin typeface="Consolas"/>
               </a:rPr>
-              <a:t>02 / 9</a:t>
+              <a:t>03 / 10</a:t>
             </a:r>
           </a:p>
         </p:txBody>
@@ -8979,7 +8979,7 @@
         <p:spPr>
           <a:xfrm>
             <a:off x="740664" y="4297680"/>
-            <a:ext cx="5449824" cy="477774"/>
+            <a:ext cx="5449824" cy="637032"/>
           </a:xfrm>
           <a:prstGeom prst="rect">
             <a:avLst/>
@@ -9004,7 +9004,7 @@
                 </a:solidFill>
                 <a:latin typeface="Segoe UI"/>
               </a:rPr>
-              <a:t>Ses 51 lignes sont déjà contenues dans les fichiers Moov et Togocom réunis, sans un seul enregistrement propre. Empiler les quatre fichiers afficherait 141 agences au lieu de 90 — 57 % de surestimation dès le premier indicateur.</a:t>
+              <a:t>Ses 51 lignes sont déjà contenues dans les fichiers Moov et Togocom réunis, sans un seul enregistrement propre. Empiler les fichiers afficherait 141 agences au lieu de 90 recensées après dédoublonnage (28 Moov, 62 Togocom), dont 88 actives : 2 agences Togocom déclarées fermées sont exclues des calculs.</a:t>
             </a:r>
           </a:p>
         </p:txBody>
@@ -9017,7 +9017,7 @@
         </p:nvSpPr>
         <p:spPr>
           <a:xfrm>
-            <a:off x="566928" y="4958334"/>
+            <a:off x="566928" y="5117592"/>
             <a:ext cx="68580" cy="68580"/>
           </a:xfrm>
           <a:prstGeom prst="rect">
@@ -9061,7 +9061,7 @@
         </p:nvSpPr>
         <p:spPr>
           <a:xfrm>
-            <a:off x="740664" y="4908042"/>
+            <a:off x="740664" y="5067300"/>
             <a:ext cx="5449824" cy="219456"/>
           </a:xfrm>
           <a:prstGeom prst="rect">
@@ -9100,7 +9100,7 @@
         </p:nvSpPr>
         <p:spPr>
           <a:xfrm>
-            <a:off x="740664" y="5136642"/>
+            <a:off x="740664" y="5295900"/>
             <a:ext cx="5449824" cy="318516"/>
           </a:xfrm>
           <a:prstGeom prst="rect">
@@ -9139,7 +9139,7 @@
         </p:nvSpPr>
         <p:spPr>
           <a:xfrm>
-            <a:off x="566928" y="5638038"/>
+            <a:off x="566928" y="5797296"/>
             <a:ext cx="68580" cy="68580"/>
           </a:xfrm>
           <a:prstGeom prst="rect">
@@ -9183,7 +9183,7 @@
         </p:nvSpPr>
         <p:spPr>
           <a:xfrm>
-            <a:off x="740664" y="5587746"/>
+            <a:off x="740664" y="5747004"/>
             <a:ext cx="5449824" cy="219456"/>
           </a:xfrm>
           <a:prstGeom prst="rect">
@@ -9222,7 +9222,7 @@
         </p:nvSpPr>
         <p:spPr>
           <a:xfrm>
-            <a:off x="740664" y="5816346"/>
+            <a:off x="740664" y="5975604"/>
             <a:ext cx="5449824" cy="477774"/>
           </a:xfrm>
           <a:prstGeom prst="rect">
@@ -9377,7 +9377,7 @@
                 </a:solidFill>
                 <a:latin typeface="Consolas"/>
               </a:rPr>
-              <a:t>25 CONTRÔLES ARITHMÉTIQUES, REJOUÉS À CHAQUE EXÉCUTION</a:t>
+              <a:t>35 CONTRÔLES ARITHMÉTIQUES, REJOUÉS À CHAQUE EXÉCUTION</a:t>
             </a:r>
           </a:p>
         </p:txBody>
@@ -9969,7 +9969,7 @@
                 </a:solidFill>
                 <a:latin typeface="Consolas"/>
               </a:rPr>
-              <a:t>03 / 9</a:t>
+              <a:t>04 / 10</a:t>
             </a:r>
           </a:p>
         </p:txBody>
@@ -10516,7 +10516,7 @@
                           </a:solidFill>
                           <a:latin typeface="Segoe UI"/>
                         </a:rPr>
-                        <a:t>agences / 100 000 hab.</a:t>
+                        <a:t>agences actives / 100 000 hab.</a:t>
                       </a:r>
                     </a:p>
                   </a:txBody>
@@ -10584,7 +10584,7 @@
                           </a:solidFill>
                           <a:latin typeface="Segoe UI"/>
                         </a:rPr>
-                        <a:t>distance médiane à une agence</a:t>
+                        <a:t>distance à l'agence active</a:t>
                       </a:r>
                     </a:p>
                   </a:txBody>
@@ -11193,7 +11193,7 @@
                 </a:solidFill>
                 <a:latin typeface="Segoe UI"/>
               </a:rPr>
-              <a:t>409 habitants par point de service en moyenne — mais un rapport de 1 à 12,7 entre la préfecture la mieux et la moins bien desservie.</a:t>
+              <a:t>409 habitants par point de service en moyenne, mais un rapport de 1 à 12,7 entre préfectures.</a:t>
             </a:r>
           </a:p>
         </p:txBody>
@@ -11315,7 +11315,7 @@
                 </a:solidFill>
                 <a:latin typeface="Consolas"/>
               </a:rPr>
-              <a:t>04 / 9</a:t>
+              <a:t>05 / 10</a:t>
             </a:r>
           </a:p>
         </p:txBody>
@@ -12089,7 +12089,7 @@
                 </a:solidFill>
                 <a:latin typeface="Consolas"/>
               </a:rPr>
-              <a:t>COMMUNES SANS AUCUNE AGENCE</a:t>
+              <a:t>COMMUNES SANS AGENCE ACTIVE</a:t>
             </a:r>
           </a:p>
         </p:txBody>
@@ -12727,7 +12727,7 @@
                 </a:solidFill>
                 <a:latin typeface="Consolas"/>
               </a:rPr>
-              <a:t>05 / 9</a:t>
+              <a:t>06 / 10</a:t>
             </a:r>
           </a:p>
         </p:txBody>
@@ -13374,7 +13374,7 @@
                 </a:solidFill>
                 <a:latin typeface="Consolas"/>
               </a:rPr>
-              <a:t>06 / 9</a:t>
+              <a:t>07 / 10</a:t>
             </a:r>
           </a:p>
         </p:txBody>
@@ -13554,7 +13554,7 @@
                           </a:solidFill>
                           <a:latin typeface="Segoe UI"/>
                         </a:rPr>
-                        <a:t>Ag.</a:t>
+                        <a:t>Ag. act.</a:t>
                       </a:r>
                     </a:p>
                   </a:txBody>
@@ -14982,7 +14982,7 @@
                 </a:solidFill>
                 <a:latin typeface="Consolas"/>
               </a:rPr>
-              <a:t>07 / 9</a:t>
+              <a:t>08 / 10</a:t>
             </a:r>
           </a:p>
         </p:txBody>
@@ -15372,7 +15372,7 @@
                 </a:solidFill>
                 <a:latin typeface="Segoe UI"/>
               </a:rPr>
-              <a:t>Déclencheur : 25 km ou plus jusqu'à une agence. Quand l'éloignement domine, un guichet au chef-lieu ne règle rien.</a:t>
+              <a:t>Déclencheur : 25 km ou plus jusqu'à une agence active. Quand l'éloignement domine, un guichet au chef-lieu ne règle rien.</a:t>
             </a:r>
           </a:p>
         </p:txBody>
@@ -16160,7 +16160,7 @@
                 </a:solidFill>
                 <a:latin typeface="Consolas"/>
               </a:rPr>
-              <a:t>08 / 9</a:t>
+              <a:t>09 / 10</a:t>
             </a:r>
           </a:p>
         </p:txBody>
@@ -16379,7 +16379,7 @@
         <p:spPr>
           <a:xfrm>
             <a:off x="740664" y="3033522"/>
-            <a:ext cx="5404104" cy="159258"/>
+            <a:ext cx="5404104" cy="318516"/>
           </a:xfrm>
           <a:prstGeom prst="rect">
             <a:avLst/>
@@ -16404,7 +16404,7 @@
                 </a:solidFill>
                 <a:latin typeface="Segoe UI"/>
               </a:rPr>
-              <a:t>Fichier source vide. Le déficit d'agences ne porte que sur Moov et Togocom.</a:t>
+              <a:t>Fichier source vide. Le déficit porte sur les 88 agences actives Moov et Togocom (2 fermées exclues sur 90 recensées).</a:t>
             </a:r>
           </a:p>
         </p:txBody>
@@ -16417,7 +16417,7 @@
         </p:nvSpPr>
         <p:spPr>
           <a:xfrm>
-            <a:off x="566928" y="3375660"/>
+            <a:off x="566928" y="3534918"/>
             <a:ext cx="68580" cy="68580"/>
           </a:xfrm>
           <a:prstGeom prst="rect">
@@ -16461,7 +16461,7 @@
         </p:nvSpPr>
         <p:spPr>
           <a:xfrm>
-            <a:off x="740664" y="3325368"/>
+            <a:off x="740664" y="3484626"/>
             <a:ext cx="5404104" cy="219456"/>
           </a:xfrm>
           <a:prstGeom prst="rect">
@@ -16500,7 +16500,7 @@
         </p:nvSpPr>
         <p:spPr>
           <a:xfrm>
-            <a:off x="740664" y="3553968"/>
+            <a:off x="740664" y="3713226"/>
             <a:ext cx="5404104" cy="318516"/>
           </a:xfrm>
           <a:prstGeom prst="rect">

</xml_diff>